<commit_message>
Make slides 3-4 accurate and consistent with slide 5
- Slide 3: same plan as slide 5 (Cloud Storage + Redis catalog, Cloud Tasks
  draft queue, one region first, SSO later), American spelling, rewritten
  speaker notes (they described the MVP diagram).
- Slide 4: 46,656 paths, 84 tests, Age +1 game flow, quizzes only on demo
  lessons; fitted to the slide so the title is no longer cropped.
- Slide 5 notes: Firestore -> Redis to match the slide.
- Production docs and pitch script aligned to the same plan.
</commit_message>
<xml_diff>
--- a/rooted_slides.pptx
+++ b/rooted_slides.pptx
@@ -461,7 +461,7 @@
           <a:p>
             <a:r>
               <a:rPr lang="en-US" dirty="0"/>
-              <a:t>Suggested time: 80 seconds. This full-slide vector diagram is the supplied architecture-mvp.svg. Left: user browser contains the profile, learning line, game, localized UI and browser storage. Center: Next.js serves static shell and a validated lesson endpoint with cache/fallback. Right: provider adapter. Bottom: schema-validated Git JSON content, build-time pipelines and CI. Vertex AI in the EU is explicitly a production target, not deployed in the MVP.</a:t>
+              <a:t>Suggested time: 80 seconds. Production target on Google Cloud (EU): a plan, not built in the MVP. Left to right: anonymous learners, the edge (Cloud CDN caches approved lessons, Cloud Armor filters traffic), Cloud Run running the same Next.js code, and Vertex AI on an EU endpoint. Data: Cloud Storage holds the versioned lesson catalog with a Redis cache in front; Cloud Tasks queues AI drafts so no learner waits on a live model call; BigQuery receives anonymized events only. Same plan as slide 5: launch in one region, add failover and bank SSO as demand grows. Bottom: zero-trust perimeter, content released separately from code with four-eyes review, and a DevSecOps pipeline.</a:t>
             </a:r>
           </a:p>
         </p:txBody>
@@ -634,7 +634,7 @@
           <a:lstStyle/>
           <a:p>
             <a:r>
-              <a:t>Enterprise scalability strategy (proposed, not MVP): Keep the deterministic game, budgeting inputs, and profile in the browser to avoid scaling a stateful game backend. Deploy a containerized, stateless Next.js API to autoscaling Cloud Run behind an HTTPS load balancer, Cloud CDN and Cloud Armor. Serve approved lesson objects from cache and a shared versioned catalog (Cloud Storage + Firestore). Generate and translate lessons asynchronously with Cloud Tasks and a hosted model in the appropriate data-residency region; apply schema checks, source attribution, and human financial-content review before publication. Enterprise guardrails: least-privilege IAM, secrets, observability, error and latency SLOs, rate/instance caps, canary deployments and rollback. Start in one EU region and add failover and enterprise SSO based on requirements and demand. Public lesson caching never includes individual financial inputs. This is an architecture proposal, not a claim of deployed infrastructure.</a:t>
+              <a:t>Enterprise scalability strategy (proposed, not MVP): Keep the deterministic game, budgeting inputs, and profile in the browser to avoid scaling a stateful game backend. Deploy a containerized, stateless Next.js API to autoscaling Cloud Run behind an HTTPS load balancer, Cloud CDN and Cloud Armor. Serve approved lesson objects from cache and a shared versioned catalog (Cloud Storage + Redis). Generate and translate lessons asynchronously with Cloud Tasks and a hosted model in the appropriate data-residency region; apply schema checks, source attribution, and human financial-content review before publication. Enterprise guardrails: least-privilege IAM, secrets, observability, error and latency SLOs, rate/instance caps, canary deployments and rollback. Start in one EU region and add failover and enterprise SSO based on requirements and demand. Public lesson caching never includes individual financial inputs. This is an architecture proposal, not a claim of deployed infrastructure.</a:t>
             </a:r>
           </a:p>
         </p:txBody>
@@ -3200,8 +3200,8 @@
         </p:blipFill>
         <p:spPr>
           <a:xfrm>
-            <a:off x="0" y="-372026"/>
-            <a:ext cx="12191970" cy="7602052"/>
+            <a:off x="596660" y="0"/>
+            <a:ext cx="10998679" cy="6858000"/>
           </a:xfrm>
           <a:prstGeom prst="rect">
             <a:avLst/>

</xml_diff>